<commit_message>
module 4 ppt added
</commit_message>
<xml_diff>
--- a/Presentations/Computer Vision – Module 3.pptx
+++ b/Presentations/Computer Vision – Module 3.pptx
@@ -4907,8 +4907,8 @@
           </a:p>
         </p:txBody>
       </p:sp>
-      <mc:AlternateContent xmlns:mc="http://schemas.openxmlformats.org/markup-compatibility/2006">
-        <mc:Choice xmlns:a14="http://schemas.microsoft.com/office/drawing/2010/main" Requires="a14">
+      <mc:AlternateContent xmlns:mc="http://schemas.openxmlformats.org/markup-compatibility/2006" xmlns:a14="http://schemas.microsoft.com/office/drawing/2010/main">
+        <mc:Choice Requires="a14">
           <p:sp>
             <p:nvSpPr>
               <p:cNvPr id="3" name="Content Placeholder 2">
@@ -4960,37 +4960,51 @@
                 <a14:m>
                   <m:oMath xmlns:m="http://schemas.openxmlformats.org/officeDocument/2006/math">
                     <m:r>
-                      <a:rPr lang="en-IN" i="1"/>
+                      <a:rPr lang="en-IN" i="1">
+                        <a:latin typeface="Cambria Math" panose="02040503050406030204" pitchFamily="18" charset="0"/>
+                      </a:rPr>
                       <m:t>𝑓</m:t>
                     </m:r>
                     <m:d>
                       <m:dPr>
                         <m:sepChr m:val=","/>
                         <m:ctrlPr>
-                          <a:rPr lang="ar-AE" i="1"/>
+                          <a:rPr lang="ar-AE" i="1">
+                            <a:latin typeface="Cambria Math" panose="02040503050406030204" pitchFamily="18" charset="0"/>
+                          </a:rPr>
                         </m:ctrlPr>
                       </m:dPr>
                       <m:e>
                         <m:r>
-                          <a:rPr lang="ar-AE" i="1"/>
+                          <a:rPr lang="ar-AE" i="1">
+                            <a:latin typeface="Cambria Math" panose="02040503050406030204" pitchFamily="18" charset="0"/>
+                          </a:rPr>
                           <m:t>𝑥</m:t>
                         </m:r>
                       </m:e>
                       <m:e>
                         <m:r>
-                          <a:rPr lang="ar-AE"/>
+                          <a:rPr lang="ar-AE">
+                            <a:latin typeface="Cambria Math" panose="02040503050406030204" pitchFamily="18" charset="0"/>
+                          </a:rPr>
                           <m:t>+</m:t>
                         </m:r>
                         <m:r>
-                          <a:rPr lang="ar-AE" i="1"/>
+                          <a:rPr lang="ar-AE" i="1">
+                            <a:latin typeface="Cambria Math" panose="02040503050406030204" pitchFamily="18" charset="0"/>
+                          </a:rPr>
                           <m:t>𝑖𝑦</m:t>
                         </m:r>
                         <m:r>
-                          <a:rPr lang="ar-AE"/>
+                          <a:rPr lang="ar-AE">
+                            <a:latin typeface="Cambria Math" panose="02040503050406030204" pitchFamily="18" charset="0"/>
+                          </a:rPr>
                           <m:t>+</m:t>
                         </m:r>
                         <m:r>
-                          <a:rPr lang="ar-AE" i="1"/>
+                          <a:rPr lang="ar-AE" i="1">
+                            <a:latin typeface="Cambria Math" panose="02040503050406030204" pitchFamily="18" charset="0"/>
+                          </a:rPr>
                           <m:t>𝑗</m:t>
                         </m:r>
                       </m:e>
@@ -5010,25 +5024,33 @@
                 <a14:m>
                   <m:oMath xmlns:m="http://schemas.openxmlformats.org/officeDocument/2006/math">
                     <m:r>
-                      <a:rPr lang="en-IN" i="1"/>
+                      <a:rPr lang="en-IN" i="1">
+                        <a:latin typeface="Cambria Math" panose="02040503050406030204" pitchFamily="18" charset="0"/>
+                      </a:rPr>
                       <m:t>𝑤</m:t>
                     </m:r>
                     <m:d>
                       <m:dPr>
                         <m:sepChr m:val=","/>
                         <m:ctrlPr>
-                          <a:rPr lang="ar-AE" i="1"/>
+                          <a:rPr lang="ar-AE" i="1">
+                            <a:latin typeface="Cambria Math" panose="02040503050406030204" pitchFamily="18" charset="0"/>
+                          </a:rPr>
                         </m:ctrlPr>
                       </m:dPr>
                       <m:e>
                         <m:r>
-                          <a:rPr lang="ar-AE" i="1"/>
+                          <a:rPr lang="ar-AE" i="1">
+                            <a:latin typeface="Cambria Math" panose="02040503050406030204" pitchFamily="18" charset="0"/>
+                          </a:rPr>
                           <m:t>𝑖</m:t>
                         </m:r>
                       </m:e>
                       <m:e>
                         <m:r>
-                          <a:rPr lang="ar-AE" i="1"/>
+                          <a:rPr lang="ar-AE" i="1">
+                            <a:latin typeface="Cambria Math" panose="02040503050406030204" pitchFamily="18" charset="0"/>
+                          </a:rPr>
                           <m:t>𝑗</m:t>
                         </m:r>
                       </m:e>
@@ -5047,7 +5069,7 @@
             </p:txBody>
           </p:sp>
         </mc:Choice>
-        <mc:Fallback>
+        <mc:Fallback xmlns="">
           <p:sp>
             <p:nvSpPr>
               <p:cNvPr id="3" name="Content Placeholder 2">
@@ -6673,8 +6695,8 @@
           </a:p>
         </p:txBody>
       </p:sp>
-      <mc:AlternateContent xmlns:mc="http://schemas.openxmlformats.org/markup-compatibility/2006">
-        <mc:Choice xmlns:a14="http://schemas.microsoft.com/office/drawing/2010/main" Requires="a14">
+      <mc:AlternateContent xmlns:mc="http://schemas.openxmlformats.org/markup-compatibility/2006" xmlns:a14="http://schemas.microsoft.com/office/drawing/2010/main">
+        <mc:Choice Requires="a14">
           <p:sp>
             <p:nvSpPr>
               <p:cNvPr id="5" name="Content Placeholder 4">
@@ -6705,7 +6727,9 @@
                 <a14:m>
                   <m:oMath xmlns:m="http://schemas.openxmlformats.org/officeDocument/2006/math">
                     <m:r>
-                      <a:rPr lang="en-IN" i="1"/>
+                      <a:rPr lang="en-IN" i="1">
+                        <a:latin typeface="Cambria Math" panose="02040503050406030204" pitchFamily="18" charset="0"/>
+                      </a:rPr>
                       <m:t>𝐼</m:t>
                     </m:r>
                   </m:oMath>
@@ -6717,7 +6741,9 @@
                 <a14:m>
                   <m:oMath xmlns:m="http://schemas.openxmlformats.org/officeDocument/2006/math">
                     <m:r>
-                      <a:rPr lang="en-IN" i="1"/>
+                      <a:rPr lang="en-IN" i="1">
+                        <a:latin typeface="Cambria Math" panose="02040503050406030204" pitchFamily="18" charset="0"/>
+                      </a:rPr>
                       <m:t>𝑛</m:t>
                     </m:r>
                   </m:oMath>
@@ -6738,97 +6764,131 @@
                     </m:oMathParaPr>
                     <m:oMath xmlns:m="http://schemas.openxmlformats.org/officeDocument/2006/math">
                       <m:r>
-                        <a:rPr lang="en-IN" i="1"/>
+                        <a:rPr lang="en-IN" i="1">
+                          <a:latin typeface="Cambria Math" panose="02040503050406030204" pitchFamily="18" charset="0"/>
+                        </a:rPr>
                         <m:t>𝐼</m:t>
                       </m:r>
                       <m:r>
-                        <a:rPr lang="en-IN"/>
+                        <a:rPr lang="en-IN">
+                          <a:latin typeface="Cambria Math" panose="02040503050406030204" pitchFamily="18" charset="0"/>
+                        </a:rPr>
                         <m:t>=</m:t>
                       </m:r>
                       <m:sSub>
                         <m:sSubPr>
                           <m:ctrlPr>
-                            <a:rPr lang="ar-AE" i="1"/>
+                            <a:rPr lang="ar-AE" i="1">
+                              <a:latin typeface="Cambria Math" panose="02040503050406030204" pitchFamily="18" charset="0"/>
+                            </a:rPr>
                           </m:ctrlPr>
                         </m:sSubPr>
                         <m:e>
                           <m:r>
-                            <a:rPr lang="ar-AE" i="1"/>
+                            <a:rPr lang="ar-AE" i="1">
+                              <a:latin typeface="Cambria Math" panose="02040503050406030204" pitchFamily="18" charset="0"/>
+                            </a:rPr>
                             <m:t>𝑅</m:t>
                           </m:r>
                         </m:e>
                         <m:sub>
                           <m:r>
-                            <a:rPr lang="ar-AE"/>
+                            <a:rPr lang="ar-AE">
+                              <a:latin typeface="Cambria Math" panose="02040503050406030204" pitchFamily="18" charset="0"/>
+                            </a:rPr>
                             <m:t>1</m:t>
                           </m:r>
                         </m:sub>
                       </m:sSub>
                       <m:r>
-                        <a:rPr lang="ar-AE"/>
+                        <a:rPr lang="ar-AE">
+                          <a:latin typeface="Cambria Math" panose="02040503050406030204" pitchFamily="18" charset="0"/>
+                        </a:rPr>
                         <m:t>∪</m:t>
                       </m:r>
                       <m:sSub>
                         <m:sSubPr>
                           <m:ctrlPr>
-                            <a:rPr lang="ar-AE" i="1"/>
+                            <a:rPr lang="ar-AE" i="1">
+                              <a:latin typeface="Cambria Math" panose="02040503050406030204" pitchFamily="18" charset="0"/>
+                            </a:rPr>
                           </m:ctrlPr>
                         </m:sSubPr>
                         <m:e>
                           <m:r>
-                            <a:rPr lang="ar-AE" i="1"/>
+                            <a:rPr lang="ar-AE" i="1">
+                              <a:latin typeface="Cambria Math" panose="02040503050406030204" pitchFamily="18" charset="0"/>
+                            </a:rPr>
                             <m:t>𝑅</m:t>
                           </m:r>
                         </m:e>
                         <m:sub>
                           <m:r>
-                            <a:rPr lang="ar-AE"/>
+                            <a:rPr lang="ar-AE">
+                              <a:latin typeface="Cambria Math" panose="02040503050406030204" pitchFamily="18" charset="0"/>
+                            </a:rPr>
                             <m:t>2</m:t>
                           </m:r>
                         </m:sub>
                       </m:sSub>
                       <m:r>
-                        <a:rPr lang="ar-AE"/>
+                        <a:rPr lang="ar-AE">
+                          <a:latin typeface="Cambria Math" panose="02040503050406030204" pitchFamily="18" charset="0"/>
+                        </a:rPr>
                         <m:t>∪</m:t>
                       </m:r>
                       <m:sSub>
                         <m:sSubPr>
                           <m:ctrlPr>
-                            <a:rPr lang="ar-AE" i="1"/>
+                            <a:rPr lang="ar-AE" i="1">
+                              <a:latin typeface="Cambria Math" panose="02040503050406030204" pitchFamily="18" charset="0"/>
+                            </a:rPr>
                           </m:ctrlPr>
                         </m:sSubPr>
                         <m:e>
                           <m:r>
-                            <a:rPr lang="ar-AE" i="1"/>
+                            <a:rPr lang="ar-AE" i="1">
+                              <a:latin typeface="Cambria Math" panose="02040503050406030204" pitchFamily="18" charset="0"/>
+                            </a:rPr>
                             <m:t>𝑅</m:t>
                           </m:r>
                         </m:e>
                         <m:sub>
                           <m:r>
-                            <a:rPr lang="ar-AE"/>
+                            <a:rPr lang="ar-AE">
+                              <a:latin typeface="Cambria Math" panose="02040503050406030204" pitchFamily="18" charset="0"/>
+                            </a:rPr>
                             <m:t>3</m:t>
                           </m:r>
                         </m:sub>
                       </m:sSub>
                       <m:r>
-                        <a:rPr lang="ar-AE"/>
+                        <a:rPr lang="ar-AE">
+                          <a:latin typeface="Cambria Math" panose="02040503050406030204" pitchFamily="18" charset="0"/>
+                        </a:rPr>
                         <m:t>∪...∪</m:t>
                       </m:r>
                       <m:sSub>
                         <m:sSubPr>
                           <m:ctrlPr>
-                            <a:rPr lang="ar-AE" i="1"/>
+                            <a:rPr lang="ar-AE" i="1">
+                              <a:latin typeface="Cambria Math" panose="02040503050406030204" pitchFamily="18" charset="0"/>
+                            </a:rPr>
                           </m:ctrlPr>
                         </m:sSubPr>
                         <m:e>
                           <m:r>
-                            <a:rPr lang="ar-AE" i="1"/>
+                            <a:rPr lang="ar-AE" i="1">
+                              <a:latin typeface="Cambria Math" panose="02040503050406030204" pitchFamily="18" charset="0"/>
+                            </a:rPr>
                             <m:t>𝑅</m:t>
                           </m:r>
                         </m:e>
                         <m:sub>
                           <m:r>
-                            <a:rPr lang="ar-AE" i="1"/>
+                            <a:rPr lang="ar-AE" i="1">
+                              <a:latin typeface="Cambria Math" panose="02040503050406030204" pitchFamily="18" charset="0"/>
+                            </a:rPr>
                             <m:t>𝑛</m:t>
                           </m:r>
                         </m:sub>
@@ -6853,18 +6913,24 @@
                     <m:sSub>
                       <m:sSubPr>
                         <m:ctrlPr>
-                          <a:rPr lang="ar-AE"/>
+                          <a:rPr lang="ar-AE" i="1">
+                            <a:latin typeface="Cambria Math" panose="02040503050406030204" pitchFamily="18" charset="0"/>
+                          </a:rPr>
                         </m:ctrlPr>
                       </m:sSubPr>
                       <m:e>
                         <m:r>
-                          <a:rPr lang="ar-AE" i="1"/>
+                          <a:rPr lang="ar-AE" i="1">
+                            <a:latin typeface="Cambria Math" panose="02040503050406030204" pitchFamily="18" charset="0"/>
+                          </a:rPr>
                           <m:t>𝑅</m:t>
                         </m:r>
                       </m:e>
                       <m:sub>
                         <m:r>
-                          <a:rPr lang="ar-AE" i="1"/>
+                          <a:rPr lang="ar-AE" i="1">
+                            <a:latin typeface="Cambria Math" panose="02040503050406030204" pitchFamily="18" charset="0"/>
+                          </a:rPr>
                           <m:t>𝑖</m:t>
                         </m:r>
                       </m:sub>
@@ -6886,51 +6952,69 @@
                     <m:sSub>
                       <m:sSubPr>
                         <m:ctrlPr>
-                          <a:rPr lang="ar-AE"/>
+                          <a:rPr lang="ar-AE" i="1">
+                            <a:latin typeface="Cambria Math" panose="02040503050406030204" pitchFamily="18" charset="0"/>
+                          </a:rPr>
                         </m:ctrlPr>
                       </m:sSubPr>
                       <m:e>
                         <m:r>
-                          <a:rPr lang="ar-AE" i="1"/>
+                          <a:rPr lang="ar-AE" i="1">
+                            <a:latin typeface="Cambria Math" panose="02040503050406030204" pitchFamily="18" charset="0"/>
+                          </a:rPr>
                           <m:t>𝑅</m:t>
                         </m:r>
                       </m:e>
                       <m:sub>
                         <m:r>
-                          <a:rPr lang="ar-AE" i="1"/>
+                          <a:rPr lang="ar-AE" i="1">
+                            <a:latin typeface="Cambria Math" panose="02040503050406030204" pitchFamily="18" charset="0"/>
+                          </a:rPr>
                           <m:t>𝑖</m:t>
                         </m:r>
                       </m:sub>
                     </m:sSub>
                     <m:r>
-                      <a:rPr lang="ar-AE"/>
+                      <a:rPr lang="ar-AE">
+                        <a:latin typeface="Cambria Math" panose="02040503050406030204" pitchFamily="18" charset="0"/>
+                      </a:rPr>
                       <m:t>∩</m:t>
                     </m:r>
                     <m:sSub>
                       <m:sSubPr>
                         <m:ctrlPr>
-                          <a:rPr lang="ar-AE" i="1"/>
+                          <a:rPr lang="ar-AE" i="1">
+                            <a:latin typeface="Cambria Math" panose="02040503050406030204" pitchFamily="18" charset="0"/>
+                          </a:rPr>
                         </m:ctrlPr>
                       </m:sSubPr>
                       <m:e>
                         <m:r>
-                          <a:rPr lang="ar-AE" i="1"/>
+                          <a:rPr lang="ar-AE" i="1">
+                            <a:latin typeface="Cambria Math" panose="02040503050406030204" pitchFamily="18" charset="0"/>
+                          </a:rPr>
                           <m:t>𝑅</m:t>
                         </m:r>
                       </m:e>
                       <m:sub>
                         <m:r>
-                          <a:rPr lang="ar-AE" i="1"/>
+                          <a:rPr lang="ar-AE" i="1">
+                            <a:latin typeface="Cambria Math" panose="02040503050406030204" pitchFamily="18" charset="0"/>
+                          </a:rPr>
                           <m:t>𝑗</m:t>
                         </m:r>
                       </m:sub>
                     </m:sSub>
                     <m:r>
-                      <a:rPr lang="ar-AE"/>
+                      <a:rPr lang="ar-AE">
+                        <a:latin typeface="Cambria Math" panose="02040503050406030204" pitchFamily="18" charset="0"/>
+                      </a:rPr>
                       <m:t>=</m:t>
                     </m:r>
                     <m:r>
-                      <a:rPr lang="ar-AE"/>
+                      <a:rPr lang="ar-AE">
+                        <a:latin typeface="Cambria Math" panose="02040503050406030204" pitchFamily="18" charset="0"/>
+                      </a:rPr>
                       <m:t>∅</m:t>
                     </m:r>
                   </m:oMath>
@@ -6942,15 +7026,21 @@
                 <a14:m>
                   <m:oMath xmlns:m="http://schemas.openxmlformats.org/officeDocument/2006/math">
                     <m:r>
-                      <a:rPr lang="en-IN" i="1"/>
+                      <a:rPr lang="en-IN" i="1">
+                        <a:latin typeface="Cambria Math" panose="02040503050406030204" pitchFamily="18" charset="0"/>
+                      </a:rPr>
                       <m:t>𝑖</m:t>
                     </m:r>
                     <m:r>
-                      <a:rPr lang="en-IN"/>
+                      <a:rPr lang="en-IN">
+                        <a:latin typeface="Cambria Math" panose="02040503050406030204" pitchFamily="18" charset="0"/>
+                      </a:rPr>
                       <m:t>≠</m:t>
                     </m:r>
                     <m:r>
-                      <a:rPr lang="en-IN" i="1"/>
+                      <a:rPr lang="en-IN" i="1">
+                        <a:latin typeface="Cambria Math" panose="02040503050406030204" pitchFamily="18" charset="0"/>
+                      </a:rPr>
                       <m:t>𝑗</m:t>
                     </m:r>
                   </m:oMath>
@@ -6977,7 +7067,7 @@
             </p:txBody>
           </p:sp>
         </mc:Choice>
-        <mc:Fallback>
+        <mc:Fallback xmlns="">
           <p:sp>
             <p:nvSpPr>
               <p:cNvPr id="5" name="Content Placeholder 4">
@@ -7396,8 +7486,8 @@
           </a:p>
         </p:txBody>
       </p:sp>
-      <mc:AlternateContent xmlns:mc="http://schemas.openxmlformats.org/markup-compatibility/2006">
-        <mc:Choice xmlns:a14="http://schemas.microsoft.com/office/drawing/2010/main" Requires="a14">
+      <mc:AlternateContent xmlns:mc="http://schemas.openxmlformats.org/markup-compatibility/2006" xmlns:a14="http://schemas.microsoft.com/office/drawing/2010/main">
+        <mc:Choice Requires="a14">
           <p:sp>
             <p:nvSpPr>
               <p:cNvPr id="3" name="Content Placeholder 2">
@@ -7440,25 +7530,33 @@
                 <a14:m>
                   <m:oMath xmlns:m="http://schemas.openxmlformats.org/officeDocument/2006/math">
                     <m:r>
-                      <a:rPr lang="en-IN" i="1"/>
+                      <a:rPr lang="en-IN" i="1">
+                        <a:latin typeface="Cambria Math" panose="02040503050406030204" pitchFamily="18" charset="0"/>
+                      </a:rPr>
                       <m:t>𝑓</m:t>
                     </m:r>
                     <m:d>
                       <m:dPr>
                         <m:sepChr m:val=","/>
                         <m:ctrlPr>
-                          <a:rPr lang="ar-AE" i="1"/>
+                          <a:rPr lang="ar-AE" i="1">
+                            <a:latin typeface="Cambria Math" panose="02040503050406030204" pitchFamily="18" charset="0"/>
+                          </a:rPr>
                         </m:ctrlPr>
                       </m:dPr>
                       <m:e>
                         <m:r>
-                          <a:rPr lang="ar-AE" i="1"/>
+                          <a:rPr lang="ar-AE" i="1">
+                            <a:latin typeface="Cambria Math" panose="02040503050406030204" pitchFamily="18" charset="0"/>
+                          </a:rPr>
                           <m:t>𝑥</m:t>
                         </m:r>
                       </m:e>
                       <m:e>
                         <m:r>
-                          <a:rPr lang="ar-AE" i="1"/>
+                          <a:rPr lang="ar-AE" i="1">
+                            <a:latin typeface="Cambria Math" panose="02040503050406030204" pitchFamily="18" charset="0"/>
+                          </a:rPr>
                           <m:t>𝑦</m:t>
                         </m:r>
                       </m:e>
@@ -7478,25 +7576,33 @@
                 <a14:m>
                   <m:oMath xmlns:m="http://schemas.openxmlformats.org/officeDocument/2006/math">
                     <m:r>
-                      <a:rPr lang="en-IN" i="1"/>
+                      <a:rPr lang="en-IN" i="1">
+                        <a:latin typeface="Cambria Math" panose="02040503050406030204" pitchFamily="18" charset="0"/>
+                      </a:rPr>
                       <m:t>𝑔</m:t>
                     </m:r>
                     <m:d>
                       <m:dPr>
                         <m:sepChr m:val=","/>
                         <m:ctrlPr>
-                          <a:rPr lang="ar-AE" i="1"/>
+                          <a:rPr lang="ar-AE" i="1">
+                            <a:latin typeface="Cambria Math" panose="02040503050406030204" pitchFamily="18" charset="0"/>
+                          </a:rPr>
                         </m:ctrlPr>
                       </m:dPr>
                       <m:e>
                         <m:r>
-                          <a:rPr lang="ar-AE" i="1"/>
+                          <a:rPr lang="ar-AE" i="1">
+                            <a:latin typeface="Cambria Math" panose="02040503050406030204" pitchFamily="18" charset="0"/>
+                          </a:rPr>
                           <m:t>𝑥</m:t>
                         </m:r>
                       </m:e>
                       <m:e>
                         <m:r>
-                          <a:rPr lang="ar-AE" i="1"/>
+                          <a:rPr lang="ar-AE" i="1">
+                            <a:latin typeface="Cambria Math" panose="02040503050406030204" pitchFamily="18" charset="0"/>
+                          </a:rPr>
                           <m:t>𝑦</m:t>
                         </m:r>
                       </m:e>
@@ -7520,7 +7626,9 @@
                 <a14:m>
                   <m:oMath xmlns:m="http://schemas.openxmlformats.org/officeDocument/2006/math">
                     <m:r>
-                      <a:rPr lang="en-IN" i="1"/>
+                      <a:rPr lang="en-IN" i="1">
+                        <a:latin typeface="Cambria Math" panose="02040503050406030204" pitchFamily="18" charset="0"/>
+                      </a:rPr>
                       <m:t>𝑇</m:t>
                     </m:r>
                   </m:oMath>
@@ -7536,7 +7644,7 @@
             </p:txBody>
           </p:sp>
         </mc:Choice>
-        <mc:Fallback>
+        <mc:Fallback xmlns="">
           <p:sp>
             <p:nvSpPr>
               <p:cNvPr id="3" name="Content Placeholder 2">
@@ -7842,8 +7950,8 @@
           </a:p>
         </p:txBody>
       </p:sp>
-      <mc:AlternateContent xmlns:mc="http://schemas.openxmlformats.org/markup-compatibility/2006">
-        <mc:Choice xmlns:a14="http://schemas.microsoft.com/office/drawing/2010/main" Requires="a14">
+      <mc:AlternateContent xmlns:mc="http://schemas.openxmlformats.org/markup-compatibility/2006" xmlns:a14="http://schemas.microsoft.com/office/drawing/2010/main">
+        <mc:Choice Requires="a14">
           <p:sp>
             <p:nvSpPr>
               <p:cNvPr id="4" name="Content Placeholder 3">
@@ -7887,31 +7995,41 @@
                 <a14:m>
                   <m:oMath xmlns:m="http://schemas.openxmlformats.org/officeDocument/2006/math">
                     <m:r>
-                      <a:rPr lang="en-IN" i="1"/>
+                      <a:rPr lang="en-IN" i="1">
+                        <a:latin typeface="Cambria Math" panose="02040503050406030204" pitchFamily="18" charset="0"/>
+                      </a:rPr>
                       <m:t>𝑔</m:t>
                     </m:r>
                     <m:d>
                       <m:dPr>
                         <m:sepChr m:val=","/>
                         <m:ctrlPr>
-                          <a:rPr lang="ar-AE" i="1"/>
+                          <a:rPr lang="ar-AE" i="1">
+                            <a:latin typeface="Cambria Math" panose="02040503050406030204" pitchFamily="18" charset="0"/>
+                          </a:rPr>
                         </m:ctrlPr>
                       </m:dPr>
                       <m:e>
                         <m:r>
-                          <a:rPr lang="ar-AE" i="1"/>
+                          <a:rPr lang="ar-AE" i="1">
+                            <a:latin typeface="Cambria Math" panose="02040503050406030204" pitchFamily="18" charset="0"/>
+                          </a:rPr>
                           <m:t>𝑥</m:t>
                         </m:r>
                       </m:e>
                       <m:e>
                         <m:r>
-                          <a:rPr lang="ar-AE" i="1"/>
+                          <a:rPr lang="ar-AE" i="1">
+                            <a:latin typeface="Cambria Math" panose="02040503050406030204" pitchFamily="18" charset="0"/>
+                          </a:rPr>
                           <m:t>𝑦</m:t>
                         </m:r>
                       </m:e>
                     </m:d>
                     <m:r>
-                      <a:rPr lang="ar-AE"/>
+                      <a:rPr lang="ar-AE">
+                        <a:latin typeface="Cambria Math" panose="02040503050406030204" pitchFamily="18" charset="0"/>
+                      </a:rPr>
                       <m:t>=</m:t>
                     </m:r>
                     <m:d>
@@ -7919,7 +8037,9 @@
                         <m:begChr m:val="{"/>
                         <m:endChr m:val=""/>
                         <m:ctrlPr>
-                          <a:rPr lang="ar-AE" i="1"/>
+                          <a:rPr lang="ar-AE" i="1">
+                            <a:latin typeface="Cambria Math" panose="02040503050406030204" pitchFamily="18" charset="0"/>
+                          </a:rPr>
                         </m:ctrlPr>
                       </m:dPr>
                       <m:e>
@@ -7935,47 +8055,63 @@
                               </m:mc>
                             </m:mcs>
                             <m:ctrlPr>
-                              <a:rPr lang="ar-AE" i="1"/>
+                              <a:rPr lang="ar-AE" i="1">
+                                <a:latin typeface="Cambria Math" panose="02040503050406030204" pitchFamily="18" charset="0"/>
+                              </a:rPr>
                             </m:ctrlPr>
                           </m:mPr>
                           <m:mr>
                             <m:e>
                               <m:r>
-                                <a:rPr lang="ar-AE"/>
+                                <a:rPr lang="ar-AE">
+                                  <a:latin typeface="Cambria Math" panose="02040503050406030204" pitchFamily="18" charset="0"/>
+                                </a:rPr>
                                 <m:t>1</m:t>
                               </m:r>
                             </m:e>
                             <m:e>
                               <m:r>
-                                <a:rPr lang="ar-AE" i="1"/>
+                                <a:rPr lang="ar-AE" i="1">
+                                  <a:latin typeface="Cambria Math" panose="02040503050406030204" pitchFamily="18" charset="0"/>
+                                </a:rPr>
                                 <m:t>𝑓</m:t>
                               </m:r>
                               <m:d>
                                 <m:dPr>
                                   <m:sepChr m:val=","/>
                                   <m:ctrlPr>
-                                    <a:rPr lang="ar-AE" i="1"/>
+                                    <a:rPr lang="ar-AE" i="1">
+                                      <a:latin typeface="Cambria Math" panose="02040503050406030204" pitchFamily="18" charset="0"/>
+                                    </a:rPr>
                                   </m:ctrlPr>
                                 </m:dPr>
                                 <m:e>
                                   <m:r>
-                                    <a:rPr lang="ar-AE" i="1"/>
+                                    <a:rPr lang="ar-AE" i="1">
+                                      <a:latin typeface="Cambria Math" panose="02040503050406030204" pitchFamily="18" charset="0"/>
+                                    </a:rPr>
                                     <m:t>𝑥</m:t>
                                   </m:r>
                                 </m:e>
                                 <m:e>
                                   <m:r>
-                                    <a:rPr lang="ar-AE" i="1"/>
+                                    <a:rPr lang="ar-AE" i="1">
+                                      <a:latin typeface="Cambria Math" panose="02040503050406030204" pitchFamily="18" charset="0"/>
+                                    </a:rPr>
                                     <m:t>𝑦</m:t>
                                   </m:r>
                                 </m:e>
                               </m:d>
                               <m:r>
-                                <a:rPr lang="ar-AE"/>
+                                <a:rPr lang="ar-AE">
+                                  <a:latin typeface="Cambria Math" panose="02040503050406030204" pitchFamily="18" charset="0"/>
+                                </a:rPr>
                                 <m:t>≥</m:t>
                               </m:r>
                               <m:r>
-                                <a:rPr lang="ar-AE" i="1"/>
+                                <a:rPr lang="ar-AE" i="1">
+                                  <a:latin typeface="Cambria Math" panose="02040503050406030204" pitchFamily="18" charset="0"/>
+                                </a:rPr>
                                 <m:t>𝑇</m:t>
                               </m:r>
                             </m:e>
@@ -7983,41 +8119,55 @@
                           <m:mr>
                             <m:e>
                               <m:r>
-                                <a:rPr lang="ar-AE"/>
+                                <a:rPr lang="ar-AE">
+                                  <a:latin typeface="Cambria Math" panose="02040503050406030204" pitchFamily="18" charset="0"/>
+                                </a:rPr>
                                 <m:t>0</m:t>
                               </m:r>
                             </m:e>
                             <m:e>
                               <m:r>
-                                <a:rPr lang="ar-AE" i="1"/>
+                                <a:rPr lang="ar-AE" i="1">
+                                  <a:latin typeface="Cambria Math" panose="02040503050406030204" pitchFamily="18" charset="0"/>
+                                </a:rPr>
                                 <m:t>𝑓</m:t>
                               </m:r>
                               <m:d>
                                 <m:dPr>
                                   <m:sepChr m:val=","/>
                                   <m:ctrlPr>
-                                    <a:rPr lang="ar-AE" i="1"/>
+                                    <a:rPr lang="ar-AE" i="1">
+                                      <a:latin typeface="Cambria Math" panose="02040503050406030204" pitchFamily="18" charset="0"/>
+                                    </a:rPr>
                                   </m:ctrlPr>
                                 </m:dPr>
                                 <m:e>
                                   <m:r>
-                                    <a:rPr lang="ar-AE" i="1"/>
+                                    <a:rPr lang="ar-AE" i="1">
+                                      <a:latin typeface="Cambria Math" panose="02040503050406030204" pitchFamily="18" charset="0"/>
+                                    </a:rPr>
                                     <m:t>𝑥</m:t>
                                   </m:r>
                                 </m:e>
                                 <m:e>
                                   <m:r>
-                                    <a:rPr lang="ar-AE" i="1"/>
+                                    <a:rPr lang="ar-AE" i="1">
+                                      <a:latin typeface="Cambria Math" panose="02040503050406030204" pitchFamily="18" charset="0"/>
+                                    </a:rPr>
                                     <m:t>𝑦</m:t>
                                   </m:r>
                                 </m:e>
                               </m:d>
                               <m:r>
-                                <a:rPr lang="ar-AE"/>
+                                <a:rPr lang="ar-AE">
+                                  <a:latin typeface="Cambria Math" panose="02040503050406030204" pitchFamily="18" charset="0"/>
+                                </a:rPr>
                                 <m:t>&lt;</m:t>
                               </m:r>
                               <m:r>
-                                <a:rPr lang="ar-AE" i="1"/>
+                                <a:rPr lang="ar-AE" i="1">
+                                  <a:latin typeface="Cambria Math" panose="02040503050406030204" pitchFamily="18" charset="0"/>
+                                </a:rPr>
                                 <m:t>𝑇</m:t>
                               </m:r>
                             </m:e>
@@ -8052,7 +8202,7 @@
             </p:txBody>
           </p:sp>
         </mc:Choice>
-        <mc:Fallback>
+        <mc:Fallback xmlns="">
           <p:sp>
             <p:nvSpPr>
               <p:cNvPr id="4" name="Content Placeholder 3">
@@ -8902,8 +9052,8 @@
           </a:p>
         </p:txBody>
       </p:sp>
-      <mc:AlternateContent xmlns:mc="http://schemas.openxmlformats.org/markup-compatibility/2006">
-        <mc:Choice xmlns:a14="http://schemas.microsoft.com/office/drawing/2010/main" Requires="a14">
+      <mc:AlternateContent xmlns:mc="http://schemas.openxmlformats.org/markup-compatibility/2006" xmlns:a14="http://schemas.microsoft.com/office/drawing/2010/main">
+        <mc:Choice Requires="a14">
           <p:sp>
             <p:nvSpPr>
               <p:cNvPr id="3" name="Content Placeholder 2">
@@ -8944,31 +9094,41 @@
                     </m:oMathParaPr>
                     <m:oMath xmlns:m="http://schemas.openxmlformats.org/officeDocument/2006/math">
                       <m:r>
-                        <a:rPr lang="en-IN" i="1"/>
+                        <a:rPr lang="en-IN" i="1">
+                          <a:latin typeface="Cambria Math" panose="02040503050406030204" pitchFamily="18" charset="0"/>
+                        </a:rPr>
                         <m:t>𝑔</m:t>
                       </m:r>
                       <m:d>
                         <m:dPr>
                           <m:sepChr m:val=","/>
                           <m:ctrlPr>
-                            <a:rPr lang="ar-AE" i="1"/>
+                            <a:rPr lang="ar-AE" i="1">
+                              <a:latin typeface="Cambria Math" panose="02040503050406030204" pitchFamily="18" charset="0"/>
+                            </a:rPr>
                           </m:ctrlPr>
                         </m:dPr>
                         <m:e>
                           <m:r>
-                            <a:rPr lang="ar-AE" i="1"/>
+                            <a:rPr lang="ar-AE" i="1">
+                              <a:latin typeface="Cambria Math" panose="02040503050406030204" pitchFamily="18" charset="0"/>
+                            </a:rPr>
                             <m:t>𝑥</m:t>
                           </m:r>
                         </m:e>
                         <m:e>
                           <m:r>
-                            <a:rPr lang="ar-AE" i="1"/>
+                            <a:rPr lang="ar-AE" i="1">
+                              <a:latin typeface="Cambria Math" panose="02040503050406030204" pitchFamily="18" charset="0"/>
+                            </a:rPr>
                             <m:t>𝑦</m:t>
                           </m:r>
                         </m:e>
                       </m:d>
                       <m:r>
-                        <a:rPr lang="ar-AE"/>
+                        <a:rPr lang="ar-AE">
+                          <a:latin typeface="Cambria Math" panose="02040503050406030204" pitchFamily="18" charset="0"/>
+                        </a:rPr>
                         <m:t>=</m:t>
                       </m:r>
                       <m:d>
@@ -8976,7 +9136,9 @@
                           <m:begChr m:val="{"/>
                           <m:endChr m:val=""/>
                           <m:ctrlPr>
-                            <a:rPr lang="ar-AE" i="1"/>
+                            <a:rPr lang="ar-AE" i="1">
+                              <a:latin typeface="Cambria Math" panose="02040503050406030204" pitchFamily="18" charset="0"/>
+                            </a:rPr>
                           </m:ctrlPr>
                         </m:dPr>
                         <m:e>
@@ -8992,65 +9154,87 @@
                                 </m:mc>
                               </m:mcs>
                               <m:ctrlPr>
-                                <a:rPr lang="ar-AE" i="1"/>
+                                <a:rPr lang="ar-AE" i="1">
+                                  <a:latin typeface="Cambria Math" panose="02040503050406030204" pitchFamily="18" charset="0"/>
+                                </a:rPr>
                               </m:ctrlPr>
                             </m:mPr>
                             <m:mr>
                               <m:e>
                                 <m:r>
-                                  <a:rPr lang="ar-AE"/>
+                                  <a:rPr lang="ar-AE">
+                                    <a:latin typeface="Cambria Math" panose="02040503050406030204" pitchFamily="18" charset="0"/>
+                                  </a:rPr>
                                   <m:t>1</m:t>
                                 </m:r>
                               </m:e>
                               <m:e>
                                 <m:r>
-                                  <a:rPr lang="ar-AE" i="1"/>
+                                  <a:rPr lang="ar-AE" i="1">
+                                    <a:latin typeface="Cambria Math" panose="02040503050406030204" pitchFamily="18" charset="0"/>
+                                  </a:rPr>
                                   <m:t>𝑓</m:t>
                                 </m:r>
                                 <m:d>
                                   <m:dPr>
                                     <m:sepChr m:val=","/>
                                     <m:ctrlPr>
-                                      <a:rPr lang="ar-AE" i="1"/>
+                                      <a:rPr lang="ar-AE" i="1">
+                                        <a:latin typeface="Cambria Math" panose="02040503050406030204" pitchFamily="18" charset="0"/>
+                                      </a:rPr>
                                     </m:ctrlPr>
                                   </m:dPr>
                                   <m:e>
                                     <m:r>
-                                      <a:rPr lang="ar-AE" i="1"/>
+                                      <a:rPr lang="ar-AE" i="1">
+                                        <a:latin typeface="Cambria Math" panose="02040503050406030204" pitchFamily="18" charset="0"/>
+                                      </a:rPr>
                                       <m:t>𝑥</m:t>
                                     </m:r>
                                   </m:e>
                                   <m:e>
                                     <m:r>
-                                      <a:rPr lang="ar-AE" i="1"/>
+                                      <a:rPr lang="ar-AE" i="1">
+                                        <a:latin typeface="Cambria Math" panose="02040503050406030204" pitchFamily="18" charset="0"/>
+                                      </a:rPr>
                                       <m:t>𝑦</m:t>
                                     </m:r>
                                   </m:e>
                                 </m:d>
                                 <m:r>
-                                  <a:rPr lang="ar-AE"/>
+                                  <a:rPr lang="ar-AE">
+                                    <a:latin typeface="Cambria Math" panose="02040503050406030204" pitchFamily="18" charset="0"/>
+                                  </a:rPr>
                                   <m:t>≥</m:t>
                                 </m:r>
                                 <m:r>
-                                  <a:rPr lang="ar-AE" i="1"/>
+                                  <a:rPr lang="ar-AE" i="1">
+                                    <a:latin typeface="Cambria Math" panose="02040503050406030204" pitchFamily="18" charset="0"/>
+                                  </a:rPr>
                                   <m:t>𝑇</m:t>
                                 </m:r>
                                 <m:d>
                                   <m:dPr>
                                     <m:sepChr m:val=","/>
                                     <m:ctrlPr>
-                                      <a:rPr lang="ar-AE" i="1"/>
+                                      <a:rPr lang="ar-AE" i="1">
+                                        <a:latin typeface="Cambria Math" panose="02040503050406030204" pitchFamily="18" charset="0"/>
+                                      </a:rPr>
                                     </m:ctrlPr>
                                   </m:dPr>
                                   <m:e>
                                     <m:r>
-                                      <a:rPr lang="ar-AE" i="1"/>
+                                      <a:rPr lang="ar-AE" i="1">
+                                        <a:latin typeface="Cambria Math" panose="02040503050406030204" pitchFamily="18" charset="0"/>
+                                      </a:rPr>
                                       <m:t>𝑥</m:t>
                                     </m:r>
                                   </m:e>
                                   <m:e>
                                     <m:r>
-                                      <a:rPr lang="ar-AE" i="1"/>
+                                      <a:rPr lang="ar-AE" i="1">
+                                        <a:latin typeface="Cambria Math" panose="02040503050406030204" pitchFamily="18" charset="0"/>
+                                      </a:rPr>
                                       <m:t>𝑦</m:t>
                                     </m:r>
                                   </m:e>
@@ -9060,59 +9244,79 @@
                             <m:mr>
                               <m:e>
                                 <m:r>
-                                  <a:rPr lang="ar-AE"/>
+                                  <a:rPr lang="ar-AE">
+                                    <a:latin typeface="Cambria Math" panose="02040503050406030204" pitchFamily="18" charset="0"/>
+                                  </a:rPr>
                                   <m:t>0</m:t>
                                 </m:r>
                               </m:e>
                               <m:e>
                                 <m:r>
-                                  <a:rPr lang="ar-AE" i="1"/>
+                                  <a:rPr lang="ar-AE" i="1">
+                                    <a:latin typeface="Cambria Math" panose="02040503050406030204" pitchFamily="18" charset="0"/>
+                                  </a:rPr>
                                   <m:t>𝑓</m:t>
                                 </m:r>
                                 <m:d>
                                   <m:dPr>
                                     <m:sepChr m:val=","/>
                                     <m:ctrlPr>
-                                      <a:rPr lang="ar-AE" i="1"/>
+                                      <a:rPr lang="ar-AE" i="1">
+                                        <a:latin typeface="Cambria Math" panose="02040503050406030204" pitchFamily="18" charset="0"/>
+                                      </a:rPr>
                                     </m:ctrlPr>
                                   </m:dPr>
                                   <m:e>
                                     <m:r>
-                                      <a:rPr lang="ar-AE" i="1"/>
+                                      <a:rPr lang="ar-AE" i="1">
+                                        <a:latin typeface="Cambria Math" panose="02040503050406030204" pitchFamily="18" charset="0"/>
+                                      </a:rPr>
                                       <m:t>𝑥</m:t>
                                     </m:r>
                                   </m:e>
                                   <m:e>
                                     <m:r>
-                                      <a:rPr lang="ar-AE" i="1"/>
+                                      <a:rPr lang="ar-AE" i="1">
+                                        <a:latin typeface="Cambria Math" panose="02040503050406030204" pitchFamily="18" charset="0"/>
+                                      </a:rPr>
                                       <m:t>𝑦</m:t>
                                     </m:r>
                                   </m:e>
                                 </m:d>
                                 <m:r>
-                                  <a:rPr lang="ar-AE"/>
+                                  <a:rPr lang="ar-AE">
+                                    <a:latin typeface="Cambria Math" panose="02040503050406030204" pitchFamily="18" charset="0"/>
+                                  </a:rPr>
                                   <m:t>&lt;</m:t>
                                 </m:r>
                                 <m:r>
-                                  <a:rPr lang="ar-AE" i="1"/>
+                                  <a:rPr lang="ar-AE" i="1">
+                                    <a:latin typeface="Cambria Math" panose="02040503050406030204" pitchFamily="18" charset="0"/>
+                                  </a:rPr>
                                   <m:t>𝑇</m:t>
                                 </m:r>
                                 <m:d>
                                   <m:dPr>
                                     <m:sepChr m:val=","/>
                                     <m:ctrlPr>
-                                      <a:rPr lang="ar-AE" i="1"/>
+                                      <a:rPr lang="ar-AE" i="1">
+                                        <a:latin typeface="Cambria Math" panose="02040503050406030204" pitchFamily="18" charset="0"/>
+                                      </a:rPr>
                                     </m:ctrlPr>
                                   </m:dPr>
                                   <m:e>
                                     <m:r>
-                                      <a:rPr lang="ar-AE" i="1"/>
+                                      <a:rPr lang="ar-AE" i="1">
+                                        <a:latin typeface="Cambria Math" panose="02040503050406030204" pitchFamily="18" charset="0"/>
+                                      </a:rPr>
                                       <m:t>𝑥</m:t>
                                     </m:r>
                                   </m:e>
                                   <m:e>
                                     <m:r>
-                                      <a:rPr lang="ar-AE" i="1"/>
+                                      <a:rPr lang="ar-AE" i="1">
+                                        <a:latin typeface="Cambria Math" panose="02040503050406030204" pitchFamily="18" charset="0"/>
+                                      </a:rPr>
                                       <m:t>𝑦</m:t>
                                     </m:r>
                                   </m:e>
@@ -9137,25 +9341,33 @@
                 <a14:m>
                   <m:oMath xmlns:m="http://schemas.openxmlformats.org/officeDocument/2006/math">
                     <m:r>
-                      <a:rPr lang="en-IN" i="1"/>
+                      <a:rPr lang="en-IN" i="1">
+                        <a:latin typeface="Cambria Math" panose="02040503050406030204" pitchFamily="18" charset="0"/>
+                      </a:rPr>
                       <m:t>𝑇</m:t>
                     </m:r>
                     <m:d>
                       <m:dPr>
                         <m:sepChr m:val=","/>
                         <m:ctrlPr>
-                          <a:rPr lang="ar-AE" i="1"/>
+                          <a:rPr lang="ar-AE" i="1">
+                            <a:latin typeface="Cambria Math" panose="02040503050406030204" pitchFamily="18" charset="0"/>
+                          </a:rPr>
                         </m:ctrlPr>
                       </m:dPr>
                       <m:e>
                         <m:r>
-                          <a:rPr lang="ar-AE" i="1"/>
+                          <a:rPr lang="ar-AE" i="1">
+                            <a:latin typeface="Cambria Math" panose="02040503050406030204" pitchFamily="18" charset="0"/>
+                          </a:rPr>
                           <m:t>𝑥</m:t>
                         </m:r>
                       </m:e>
                       <m:e>
                         <m:r>
-                          <a:rPr lang="ar-AE" i="1"/>
+                          <a:rPr lang="ar-AE" i="1">
+                            <a:latin typeface="Cambria Math" panose="02040503050406030204" pitchFamily="18" charset="0"/>
+                          </a:rPr>
                           <m:t>𝑦</m:t>
                         </m:r>
                       </m:e>
@@ -9182,7 +9394,7 @@
             </p:txBody>
           </p:sp>
         </mc:Choice>
-        <mc:Fallback>
+        <mc:Fallback xmlns="">
           <p:sp>
             <p:nvSpPr>
               <p:cNvPr id="3" name="Content Placeholder 2">
@@ -9280,8 +9492,8 @@
           </a:p>
         </p:txBody>
       </p:sp>
-      <mc:AlternateContent xmlns:mc="http://schemas.openxmlformats.org/markup-compatibility/2006">
-        <mc:Choice xmlns:a14="http://schemas.microsoft.com/office/drawing/2010/main" Requires="a14">
+      <mc:AlternateContent xmlns:mc="http://schemas.openxmlformats.org/markup-compatibility/2006" xmlns:a14="http://schemas.microsoft.com/office/drawing/2010/main">
+        <mc:Choice Requires="a14">
           <p:sp>
             <p:nvSpPr>
               <p:cNvPr id="3" name="Content Placeholder 2">
@@ -9319,31 +9531,41 @@
                     </m:oMathParaPr>
                     <m:oMath xmlns:m="http://schemas.openxmlformats.org/officeDocument/2006/math">
                       <m:r>
-                        <a:rPr lang="en-IN" i="1"/>
+                        <a:rPr lang="en-IN" i="1">
+                          <a:latin typeface="Cambria Math" panose="02040503050406030204" pitchFamily="18" charset="0"/>
+                        </a:rPr>
                         <m:t>𝑔</m:t>
                       </m:r>
                       <m:d>
                         <m:dPr>
                           <m:sepChr m:val=","/>
                           <m:ctrlPr>
-                            <a:rPr lang="ar-AE" i="1"/>
+                            <a:rPr lang="ar-AE" i="1">
+                              <a:latin typeface="Cambria Math" panose="02040503050406030204" pitchFamily="18" charset="0"/>
+                            </a:rPr>
                           </m:ctrlPr>
                         </m:dPr>
                         <m:e>
                           <m:r>
-                            <a:rPr lang="ar-AE" i="1"/>
+                            <a:rPr lang="ar-AE" i="1">
+                              <a:latin typeface="Cambria Math" panose="02040503050406030204" pitchFamily="18" charset="0"/>
+                            </a:rPr>
                             <m:t>𝑥</m:t>
                           </m:r>
                         </m:e>
                         <m:e>
                           <m:r>
-                            <a:rPr lang="ar-AE" i="1"/>
+                            <a:rPr lang="ar-AE" i="1">
+                              <a:latin typeface="Cambria Math" panose="02040503050406030204" pitchFamily="18" charset="0"/>
+                            </a:rPr>
                             <m:t>𝑦</m:t>
                           </m:r>
                         </m:e>
                       </m:d>
                       <m:r>
-                        <a:rPr lang="ar-AE"/>
+                        <a:rPr lang="ar-AE">
+                          <a:latin typeface="Cambria Math" panose="02040503050406030204" pitchFamily="18" charset="0"/>
+                        </a:rPr>
                         <m:t>=</m:t>
                       </m:r>
                       <m:d>
@@ -9351,7 +9573,9 @@
                           <m:begChr m:val="{"/>
                           <m:endChr m:val=""/>
                           <m:ctrlPr>
-                            <a:rPr lang="ar-AE" i="1"/>
+                            <a:rPr lang="ar-AE" i="1">
+                              <a:latin typeface="Cambria Math" panose="02040503050406030204" pitchFamily="18" charset="0"/>
+                            </a:rPr>
                           </m:ctrlPr>
                         </m:dPr>
                         <m:e>
@@ -9367,65 +9591,87 @@
                                 </m:mc>
                               </m:mcs>
                               <m:ctrlPr>
-                                <a:rPr lang="ar-AE" i="1"/>
+                                <a:rPr lang="ar-AE" i="1">
+                                  <a:latin typeface="Cambria Math" panose="02040503050406030204" pitchFamily="18" charset="0"/>
+                                </a:rPr>
                               </m:ctrlPr>
                             </m:mPr>
                             <m:mr>
                               <m:e>
                                 <m:r>
-                                  <a:rPr lang="ar-AE"/>
+                                  <a:rPr lang="ar-AE">
+                                    <a:latin typeface="Cambria Math" panose="02040503050406030204" pitchFamily="18" charset="0"/>
+                                  </a:rPr>
                                   <m:t>1</m:t>
                                 </m:r>
                               </m:e>
                               <m:e>
                                 <m:r>
-                                  <a:rPr lang="ar-AE" i="1"/>
+                                  <a:rPr lang="ar-AE" i="1">
+                                    <a:latin typeface="Cambria Math" panose="02040503050406030204" pitchFamily="18" charset="0"/>
+                                  </a:rPr>
                                   <m:t>𝑓</m:t>
                                 </m:r>
                                 <m:d>
                                   <m:dPr>
                                     <m:sepChr m:val=","/>
                                     <m:ctrlPr>
-                                      <a:rPr lang="ar-AE" i="1"/>
+                                      <a:rPr lang="ar-AE" i="1">
+                                        <a:latin typeface="Cambria Math" panose="02040503050406030204" pitchFamily="18" charset="0"/>
+                                      </a:rPr>
                                     </m:ctrlPr>
                                   </m:dPr>
                                   <m:e>
                                     <m:r>
-                                      <a:rPr lang="ar-AE" i="1"/>
+                                      <a:rPr lang="ar-AE" i="1">
+                                        <a:latin typeface="Cambria Math" panose="02040503050406030204" pitchFamily="18" charset="0"/>
+                                      </a:rPr>
                                       <m:t>𝑥</m:t>
                                     </m:r>
                                   </m:e>
                                   <m:e>
                                     <m:r>
-                                      <a:rPr lang="ar-AE" i="1"/>
+                                      <a:rPr lang="ar-AE" i="1">
+                                        <a:latin typeface="Cambria Math" panose="02040503050406030204" pitchFamily="18" charset="0"/>
+                                      </a:rPr>
                                       <m:t>𝑦</m:t>
                                     </m:r>
                                   </m:e>
                                 </m:d>
                                 <m:r>
-                                  <a:rPr lang="ar-AE"/>
+                                  <a:rPr lang="ar-AE">
+                                    <a:latin typeface="Cambria Math" panose="02040503050406030204" pitchFamily="18" charset="0"/>
+                                  </a:rPr>
                                   <m:t>≥</m:t>
                                 </m:r>
                                 <m:r>
-                                  <a:rPr lang="ar-AE" i="1"/>
+                                  <a:rPr lang="ar-AE" i="1">
+                                    <a:latin typeface="Cambria Math" panose="02040503050406030204" pitchFamily="18" charset="0"/>
+                                  </a:rPr>
                                   <m:t>𝑇</m:t>
                                 </m:r>
                                 <m:d>
                                   <m:dPr>
                                     <m:sepChr m:val=","/>
                                     <m:ctrlPr>
-                                      <a:rPr lang="ar-AE" i="1"/>
+                                      <a:rPr lang="ar-AE" i="1">
+                                        <a:latin typeface="Cambria Math" panose="02040503050406030204" pitchFamily="18" charset="0"/>
+                                      </a:rPr>
                                     </m:ctrlPr>
                                   </m:dPr>
                                   <m:e>
                                     <m:r>
-                                      <a:rPr lang="ar-AE" i="1"/>
+                                      <a:rPr lang="ar-AE" i="1">
+                                        <a:latin typeface="Cambria Math" panose="02040503050406030204" pitchFamily="18" charset="0"/>
+                                      </a:rPr>
                                       <m:t>𝑥</m:t>
                                     </m:r>
                                   </m:e>
                                   <m:e>
                                     <m:r>
-                                      <a:rPr lang="ar-AE" i="1"/>
+                                      <a:rPr lang="ar-AE" i="1">
+                                        <a:latin typeface="Cambria Math" panose="02040503050406030204" pitchFamily="18" charset="0"/>
+                                      </a:rPr>
                                       <m:t>𝑦</m:t>
                                     </m:r>
                                   </m:e>
@@ -9435,59 +9681,79 @@
                             <m:mr>
                               <m:e>
                                 <m:r>
-                                  <a:rPr lang="ar-AE"/>
+                                  <a:rPr lang="ar-AE">
+                                    <a:latin typeface="Cambria Math" panose="02040503050406030204" pitchFamily="18" charset="0"/>
+                                  </a:rPr>
                                   <m:t>0</m:t>
                                 </m:r>
                               </m:e>
                               <m:e>
                                 <m:r>
-                                  <a:rPr lang="ar-AE" i="1"/>
+                                  <a:rPr lang="ar-AE" i="1">
+                                    <a:latin typeface="Cambria Math" panose="02040503050406030204" pitchFamily="18" charset="0"/>
+                                  </a:rPr>
                                   <m:t>𝑓</m:t>
                                 </m:r>
                                 <m:d>
                                   <m:dPr>
                                     <m:sepChr m:val=","/>
                                     <m:ctrlPr>
-                                      <a:rPr lang="ar-AE" i="1"/>
+                                      <a:rPr lang="ar-AE" i="1">
+                                        <a:latin typeface="Cambria Math" panose="02040503050406030204" pitchFamily="18" charset="0"/>
+                                      </a:rPr>
                                     </m:ctrlPr>
                                   </m:dPr>
                                   <m:e>
                                     <m:r>
-                                      <a:rPr lang="ar-AE" i="1"/>
+                                      <a:rPr lang="ar-AE" i="1">
+                                        <a:latin typeface="Cambria Math" panose="02040503050406030204" pitchFamily="18" charset="0"/>
+                                      </a:rPr>
                                       <m:t>𝑥</m:t>
                                     </m:r>
                                   </m:e>
                                   <m:e>
                                     <m:r>
-                                      <a:rPr lang="ar-AE" i="1"/>
+                                      <a:rPr lang="ar-AE" i="1">
+                                        <a:latin typeface="Cambria Math" panose="02040503050406030204" pitchFamily="18" charset="0"/>
+                                      </a:rPr>
                                       <m:t>𝑦</m:t>
                                     </m:r>
                                   </m:e>
                                 </m:d>
                                 <m:r>
-                                  <a:rPr lang="ar-AE"/>
+                                  <a:rPr lang="ar-AE">
+                                    <a:latin typeface="Cambria Math" panose="02040503050406030204" pitchFamily="18" charset="0"/>
+                                  </a:rPr>
                                   <m:t>&lt;</m:t>
                                 </m:r>
                                 <m:r>
-                                  <a:rPr lang="ar-AE" i="1"/>
+                                  <a:rPr lang="ar-AE" i="1">
+                                    <a:latin typeface="Cambria Math" panose="02040503050406030204" pitchFamily="18" charset="0"/>
+                                  </a:rPr>
                                   <m:t>𝑇</m:t>
                                 </m:r>
                                 <m:d>
                                   <m:dPr>
                                     <m:sepChr m:val=","/>
                                     <m:ctrlPr>
-                                      <a:rPr lang="ar-AE" i="1"/>
+                                      <a:rPr lang="ar-AE" i="1">
+                                        <a:latin typeface="Cambria Math" panose="02040503050406030204" pitchFamily="18" charset="0"/>
+                                      </a:rPr>
                                     </m:ctrlPr>
                                   </m:dPr>
                                   <m:e>
                                     <m:r>
-                                      <a:rPr lang="ar-AE" i="1"/>
+                                      <a:rPr lang="ar-AE" i="1">
+                                        <a:latin typeface="Cambria Math" panose="02040503050406030204" pitchFamily="18" charset="0"/>
+                                      </a:rPr>
                                       <m:t>𝑥</m:t>
                                     </m:r>
                                   </m:e>
                                   <m:e>
                                     <m:r>
-                                      <a:rPr lang="ar-AE" i="1"/>
+                                      <a:rPr lang="ar-AE" i="1">
+                                        <a:latin typeface="Cambria Math" panose="02040503050406030204" pitchFamily="18" charset="0"/>
+                                      </a:rPr>
                                       <m:t>𝑦</m:t>
                                     </m:r>
                                   </m:e>
@@ -9515,25 +9781,33 @@
                 <a14:m>
                   <m:oMath xmlns:m="http://schemas.openxmlformats.org/officeDocument/2006/math">
                     <m:r>
-                      <a:rPr lang="en-IN" i="1"/>
+                      <a:rPr lang="en-IN" i="1">
+                        <a:latin typeface="Cambria Math" panose="02040503050406030204" pitchFamily="18" charset="0"/>
+                      </a:rPr>
                       <m:t>𝑇</m:t>
                     </m:r>
                     <m:d>
                       <m:dPr>
                         <m:sepChr m:val=","/>
                         <m:ctrlPr>
-                          <a:rPr lang="ar-AE" i="1"/>
+                          <a:rPr lang="ar-AE" i="1">
+                            <a:latin typeface="Cambria Math" panose="02040503050406030204" pitchFamily="18" charset="0"/>
+                          </a:rPr>
                         </m:ctrlPr>
                       </m:dPr>
                       <m:e>
                         <m:r>
-                          <a:rPr lang="ar-AE" i="1"/>
+                          <a:rPr lang="ar-AE" i="1">
+                            <a:latin typeface="Cambria Math" panose="02040503050406030204" pitchFamily="18" charset="0"/>
+                          </a:rPr>
                           <m:t>𝑥</m:t>
                         </m:r>
                       </m:e>
                       <m:e>
                         <m:r>
-                          <a:rPr lang="ar-AE" i="1"/>
+                          <a:rPr lang="ar-AE" i="1">
+                            <a:latin typeface="Cambria Math" panose="02040503050406030204" pitchFamily="18" charset="0"/>
+                          </a:rPr>
                           <m:t>𝑦</m:t>
                         </m:r>
                       </m:e>
@@ -9563,7 +9837,7 @@
             </p:txBody>
           </p:sp>
         </mc:Choice>
-        <mc:Fallback>
+        <mc:Fallback xmlns="">
           <p:sp>
             <p:nvSpPr>
               <p:cNvPr id="3" name="Content Placeholder 2">
@@ -10395,8 +10669,8 @@
           </a:p>
         </p:txBody>
       </p:sp>
-      <mc:AlternateContent xmlns:mc="http://schemas.openxmlformats.org/markup-compatibility/2006">
-        <mc:Choice xmlns:a14="http://schemas.microsoft.com/office/drawing/2010/main" Requires="a14">
+      <mc:AlternateContent xmlns:mc="http://schemas.openxmlformats.org/markup-compatibility/2006" xmlns:a14="http://schemas.microsoft.com/office/drawing/2010/main">
+        <mc:Choice Requires="a14">
           <p:sp>
             <p:nvSpPr>
               <p:cNvPr id="3" name="Content Placeholder 2">
@@ -10447,81 +10721,109 @@
                     </m:oMathParaPr>
                     <m:oMath xmlns:m="http://schemas.openxmlformats.org/officeDocument/2006/math">
                       <m:r>
-                        <a:rPr lang="en-IN" i="1"/>
+                        <a:rPr lang="en-IN" i="1">
+                          <a:latin typeface="Cambria Math" panose="02040503050406030204" pitchFamily="18" charset="0"/>
+                        </a:rPr>
                         <m:t>𝑓</m:t>
                       </m:r>
                       <m:d>
                         <m:dPr>
                           <m:sepChr m:val=","/>
                           <m:ctrlPr>
-                            <a:rPr lang="ar-AE" i="1"/>
+                            <a:rPr lang="ar-AE" i="1">
+                              <a:latin typeface="Cambria Math" panose="02040503050406030204" pitchFamily="18" charset="0"/>
+                            </a:rPr>
                           </m:ctrlPr>
                         </m:dPr>
                         <m:e>
                           <m:r>
-                            <a:rPr lang="ar-AE" i="1"/>
+                            <a:rPr lang="ar-AE" i="1">
+                              <a:latin typeface="Cambria Math" panose="02040503050406030204" pitchFamily="18" charset="0"/>
+                            </a:rPr>
                             <m:t>𝑥</m:t>
                           </m:r>
                         </m:e>
                         <m:e>
                           <m:r>
-                            <a:rPr lang="ar-AE" i="1"/>
+                            <a:rPr lang="ar-AE" i="1">
+                              <a:latin typeface="Cambria Math" panose="02040503050406030204" pitchFamily="18" charset="0"/>
+                            </a:rPr>
                             <m:t>𝑦</m:t>
                           </m:r>
                         </m:e>
                       </m:d>
                       <m:r>
-                        <a:rPr lang="ar-AE"/>
+                        <a:rPr lang="ar-AE">
+                          <a:latin typeface="Cambria Math" panose="02040503050406030204" pitchFamily="18" charset="0"/>
+                        </a:rPr>
                         <m:t>=</m:t>
                       </m:r>
                       <m:r>
-                        <a:rPr lang="ar-AE" i="1"/>
+                        <a:rPr lang="ar-AE" i="1">
+                          <a:latin typeface="Cambria Math" panose="02040503050406030204" pitchFamily="18" charset="0"/>
+                        </a:rPr>
                         <m:t>𝑓</m:t>
                       </m:r>
                       <m:d>
                         <m:dPr>
                           <m:sepChr m:val=","/>
                           <m:ctrlPr>
-                            <a:rPr lang="ar-AE" i="1"/>
+                            <a:rPr lang="ar-AE" i="1">
+                              <a:latin typeface="Cambria Math" panose="02040503050406030204" pitchFamily="18" charset="0"/>
+                            </a:rPr>
                           </m:ctrlPr>
                         </m:dPr>
                         <m:e>
                           <m:r>
-                            <a:rPr lang="ar-AE" i="1"/>
+                            <a:rPr lang="ar-AE" i="1">
+                              <a:latin typeface="Cambria Math" panose="02040503050406030204" pitchFamily="18" charset="0"/>
+                            </a:rPr>
                             <m:t>𝑟</m:t>
                           </m:r>
                         </m:e>
                         <m:e>
                           <m:r>
-                            <a:rPr lang="ar-AE" i="1"/>
+                            <a:rPr lang="ar-AE" i="1">
+                              <a:latin typeface="Cambria Math" panose="02040503050406030204" pitchFamily="18" charset="0"/>
+                            </a:rPr>
                             <m:t>𝑜𝑢𝑛𝑑</m:t>
                           </m:r>
                           <m:d>
                             <m:dPr>
                               <m:ctrlPr>
-                                <a:rPr lang="ar-AE" i="1"/>
+                                <a:rPr lang="ar-AE" i="1">
+                                  <a:latin typeface="Cambria Math" panose="02040503050406030204" pitchFamily="18" charset="0"/>
+                                </a:rPr>
                               </m:ctrlPr>
                             </m:dPr>
                             <m:e>
                               <m:r>
-                                <a:rPr lang="ar-AE" i="1"/>
+                                <a:rPr lang="ar-AE" i="1">
+                                  <a:latin typeface="Cambria Math" panose="02040503050406030204" pitchFamily="18" charset="0"/>
+                                </a:rPr>
                                 <m:t>𝑥</m:t>
                               </m:r>
                             </m:e>
                           </m:d>
                           <m:r>
-                            <a:rPr lang="ar-AE" i="1"/>
+                            <a:rPr lang="ar-AE" i="1">
+                              <a:latin typeface="Cambria Math" panose="02040503050406030204" pitchFamily="18" charset="0"/>
+                            </a:rPr>
                             <m:t>𝑟𝑜𝑢𝑛𝑑</m:t>
                           </m:r>
                           <m:d>
                             <m:dPr>
                               <m:ctrlPr>
-                                <a:rPr lang="ar-AE" i="1"/>
+                                <a:rPr lang="ar-AE" i="1">
+                                  <a:latin typeface="Cambria Math" panose="02040503050406030204" pitchFamily="18" charset="0"/>
+                                </a:rPr>
                               </m:ctrlPr>
                             </m:dPr>
                             <m:e>
                               <m:r>
-                                <a:rPr lang="ar-AE" i="1"/>
+                                <a:rPr lang="ar-AE" i="1">
+                                  <a:latin typeface="Cambria Math" panose="02040503050406030204" pitchFamily="18" charset="0"/>
+                                </a:rPr>
                                 <m:t>𝑦</m:t>
                               </m:r>
                             </m:e>
@@ -10546,25 +10848,33 @@
                 <a14:m>
                   <m:oMath xmlns:m="http://schemas.openxmlformats.org/officeDocument/2006/math">
                     <m:r>
-                      <a:rPr lang="en-IN" i="1"/>
+                      <a:rPr lang="en-IN" i="1">
+                        <a:latin typeface="Cambria Math" panose="02040503050406030204" pitchFamily="18" charset="0"/>
+                      </a:rPr>
                       <m:t>𝑓</m:t>
                     </m:r>
                     <m:d>
                       <m:dPr>
                         <m:sepChr m:val=","/>
                         <m:ctrlPr>
-                          <a:rPr lang="ar-AE" i="1"/>
+                          <a:rPr lang="ar-AE" i="1">
+                            <a:latin typeface="Cambria Math" panose="02040503050406030204" pitchFamily="18" charset="0"/>
+                          </a:rPr>
                         </m:ctrlPr>
                       </m:dPr>
                       <m:e>
                         <m:r>
-                          <a:rPr lang="ar-AE" i="1"/>
+                          <a:rPr lang="ar-AE" i="1">
+                            <a:latin typeface="Cambria Math" panose="02040503050406030204" pitchFamily="18" charset="0"/>
+                          </a:rPr>
                           <m:t>𝑥</m:t>
                         </m:r>
                       </m:e>
                       <m:e>
                         <m:r>
-                          <a:rPr lang="ar-AE" i="1"/>
+                          <a:rPr lang="ar-AE" i="1">
+                            <a:latin typeface="Cambria Math" panose="02040503050406030204" pitchFamily="18" charset="0"/>
+                          </a:rPr>
                           <m:t>𝑦</m:t>
                         </m:r>
                       </m:e>
@@ -10584,39 +10894,53 @@
                 <a14:m>
                   <m:oMath xmlns:m="http://schemas.openxmlformats.org/officeDocument/2006/math">
                     <m:r>
-                      <a:rPr lang="en-IN" i="1"/>
+                      <a:rPr lang="en-IN" i="1">
+                        <a:latin typeface="Cambria Math" panose="02040503050406030204" pitchFamily="18" charset="0"/>
+                      </a:rPr>
                       <m:t>𝑟𝑜𝑢𝑛𝑑</m:t>
                     </m:r>
                     <m:d>
                       <m:dPr>
                         <m:ctrlPr>
-                          <a:rPr lang="ar-AE" i="1"/>
+                          <a:rPr lang="ar-AE" i="1">
+                            <a:latin typeface="Cambria Math" panose="02040503050406030204" pitchFamily="18" charset="0"/>
+                          </a:rPr>
                         </m:ctrlPr>
                       </m:dPr>
                       <m:e>
                         <m:r>
-                          <a:rPr lang="ar-AE" i="1"/>
+                          <a:rPr lang="ar-AE" i="1">
+                            <a:latin typeface="Cambria Math" panose="02040503050406030204" pitchFamily="18" charset="0"/>
+                          </a:rPr>
                           <m:t>𝑥</m:t>
                         </m:r>
                       </m:e>
                     </m:d>
                     <m:r>
-                      <a:rPr lang="ar-AE"/>
+                      <a:rPr lang="ar-AE">
+                        <a:latin typeface="Cambria Math" panose="02040503050406030204" pitchFamily="18" charset="0"/>
+                      </a:rPr>
                       <m:t>,</m:t>
                     </m:r>
                     <m:r>
-                      <a:rPr lang="ar-AE" i="1"/>
+                      <a:rPr lang="ar-AE" i="1">
+                        <a:latin typeface="Cambria Math" panose="02040503050406030204" pitchFamily="18" charset="0"/>
+                      </a:rPr>
                       <m:t>𝑟𝑜𝑢𝑛𝑑</m:t>
                     </m:r>
                     <m:d>
                       <m:dPr>
                         <m:ctrlPr>
-                          <a:rPr lang="ar-AE" i="1"/>
+                          <a:rPr lang="ar-AE" i="1">
+                            <a:latin typeface="Cambria Math" panose="02040503050406030204" pitchFamily="18" charset="0"/>
+                          </a:rPr>
                         </m:ctrlPr>
                       </m:dPr>
                       <m:e>
                         <m:r>
-                          <a:rPr lang="ar-AE" i="1"/>
+                          <a:rPr lang="ar-AE" i="1">
+                            <a:latin typeface="Cambria Math" panose="02040503050406030204" pitchFamily="18" charset="0"/>
+                          </a:rPr>
                           <m:t>𝑦</m:t>
                         </m:r>
                       </m:e>
@@ -10638,7 +10962,7 @@
             </p:txBody>
           </p:sp>
         </mc:Choice>
-        <mc:Fallback>
+        <mc:Fallback xmlns="">
           <p:sp>
             <p:nvSpPr>
               <p:cNvPr id="3" name="Content Placeholder 2">
@@ -11377,8 +11701,8 @@
           </a:p>
         </p:txBody>
       </p:sp>
-      <mc:AlternateContent xmlns:mc="http://schemas.openxmlformats.org/markup-compatibility/2006">
-        <mc:Choice xmlns:a14="http://schemas.microsoft.com/office/drawing/2010/main" Requires="a14">
+      <mc:AlternateContent xmlns:mc="http://schemas.openxmlformats.org/markup-compatibility/2006" xmlns:a14="http://schemas.microsoft.com/office/drawing/2010/main">
+        <mc:Choice Requires="a14">
           <p:sp>
             <p:nvSpPr>
               <p:cNvPr id="3" name="Content Placeholder 2">
@@ -11478,53 +11802,71 @@
                       <m:sSub>
                         <m:sSubPr>
                           <m:ctrlPr>
-                            <a:rPr lang="ar-AE"/>
+                            <a:rPr lang="ar-AE" i="1">
+                              <a:latin typeface="Cambria Math" panose="02040503050406030204" pitchFamily="18" charset="0"/>
+                            </a:rPr>
                           </m:ctrlPr>
                         </m:sSubPr>
                         <m:e>
                           <m:r>
-                            <a:rPr lang="ar-AE" i="1"/>
+                            <a:rPr lang="ar-AE" i="1">
+                              <a:latin typeface="Cambria Math" panose="02040503050406030204" pitchFamily="18" charset="0"/>
+                            </a:rPr>
                             <m:t>𝑄</m:t>
                           </m:r>
                         </m:e>
                         <m:sub>
                           <m:r>
-                            <a:rPr lang="ar-AE"/>
+                            <a:rPr lang="ar-AE">
+                              <a:latin typeface="Cambria Math" panose="02040503050406030204" pitchFamily="18" charset="0"/>
+                            </a:rPr>
                             <m:t>11</m:t>
                           </m:r>
                         </m:sub>
                       </m:sSub>
                       <m:r>
-                        <a:rPr lang="ar-AE"/>
+                        <a:rPr lang="ar-AE">
+                          <a:latin typeface="Cambria Math" panose="02040503050406030204" pitchFamily="18" charset="0"/>
+                        </a:rPr>
                         <m:t>=</m:t>
                       </m:r>
                       <m:r>
-                        <a:rPr lang="ar-AE" i="1"/>
+                        <a:rPr lang="ar-AE" i="1">
+                          <a:latin typeface="Cambria Math" panose="02040503050406030204" pitchFamily="18" charset="0"/>
+                        </a:rPr>
                         <m:t>𝑓</m:t>
                       </m:r>
                       <m:d>
                         <m:dPr>
                           <m:sepChr m:val=","/>
                           <m:ctrlPr>
-                            <a:rPr lang="ar-AE" i="1"/>
+                            <a:rPr lang="ar-AE" i="1">
+                              <a:latin typeface="Cambria Math" panose="02040503050406030204" pitchFamily="18" charset="0"/>
+                            </a:rPr>
                           </m:ctrlPr>
                         </m:dPr>
                         <m:e>
                           <m:sSub>
                             <m:sSubPr>
                               <m:ctrlPr>
-                                <a:rPr lang="ar-AE" i="1"/>
+                                <a:rPr lang="ar-AE" i="1">
+                                  <a:latin typeface="Cambria Math" panose="02040503050406030204" pitchFamily="18" charset="0"/>
+                                </a:rPr>
                               </m:ctrlPr>
                             </m:sSubPr>
                             <m:e>
                               <m:r>
-                                <a:rPr lang="ar-AE" i="1"/>
+                                <a:rPr lang="ar-AE" i="1">
+                                  <a:latin typeface="Cambria Math" panose="02040503050406030204" pitchFamily="18" charset="0"/>
+                                </a:rPr>
                                 <m:t>𝑥</m:t>
                               </m:r>
                             </m:e>
                             <m:sub>
                               <m:r>
-                                <a:rPr lang="ar-AE"/>
+                                <a:rPr lang="ar-AE">
+                                  <a:latin typeface="Cambria Math" panose="02040503050406030204" pitchFamily="18" charset="0"/>
+                                </a:rPr>
                                 <m:t>1</m:t>
                               </m:r>
                             </m:sub>
@@ -11534,18 +11876,24 @@
                           <m:sSub>
                             <m:sSubPr>
                               <m:ctrlPr>
-                                <a:rPr lang="ar-AE" i="1"/>
+                                <a:rPr lang="ar-AE" i="1">
+                                  <a:latin typeface="Cambria Math" panose="02040503050406030204" pitchFamily="18" charset="0"/>
+                                </a:rPr>
                               </m:ctrlPr>
                             </m:sSubPr>
                             <m:e>
                               <m:r>
-                                <a:rPr lang="ar-AE" i="1"/>
+                                <a:rPr lang="ar-AE" i="1">
+                                  <a:latin typeface="Cambria Math" panose="02040503050406030204" pitchFamily="18" charset="0"/>
+                                </a:rPr>
                                 <m:t>𝑦</m:t>
                               </m:r>
                             </m:e>
                             <m:sub>
                               <m:r>
-                                <a:rPr lang="ar-AE"/>
+                                <a:rPr lang="ar-AE">
+                                  <a:latin typeface="Cambria Math" panose="02040503050406030204" pitchFamily="18" charset="0"/>
+                                </a:rPr>
                                 <m:t>1</m:t>
                               </m:r>
                             </m:sub>
@@ -11570,53 +11918,71 @@
                       <m:sSub>
                         <m:sSubPr>
                           <m:ctrlPr>
-                            <a:rPr lang="ar-AE"/>
+                            <a:rPr lang="ar-AE" i="1">
+                              <a:latin typeface="Cambria Math" panose="02040503050406030204" pitchFamily="18" charset="0"/>
+                            </a:rPr>
                           </m:ctrlPr>
                         </m:sSubPr>
                         <m:e>
                           <m:r>
-                            <a:rPr lang="ar-AE" i="1"/>
+                            <a:rPr lang="ar-AE" i="1">
+                              <a:latin typeface="Cambria Math" panose="02040503050406030204" pitchFamily="18" charset="0"/>
+                            </a:rPr>
                             <m:t>𝑄</m:t>
                           </m:r>
                         </m:e>
                         <m:sub>
                           <m:r>
-                            <a:rPr lang="ar-AE"/>
+                            <a:rPr lang="ar-AE">
+                              <a:latin typeface="Cambria Math" panose="02040503050406030204" pitchFamily="18" charset="0"/>
+                            </a:rPr>
                             <m:t>21</m:t>
                           </m:r>
                         </m:sub>
                       </m:sSub>
                       <m:r>
-                        <a:rPr lang="ar-AE"/>
+                        <a:rPr lang="ar-AE">
+                          <a:latin typeface="Cambria Math" panose="02040503050406030204" pitchFamily="18" charset="0"/>
+                        </a:rPr>
                         <m:t>=</m:t>
                       </m:r>
                       <m:r>
-                        <a:rPr lang="ar-AE" i="1"/>
+                        <a:rPr lang="ar-AE" i="1">
+                          <a:latin typeface="Cambria Math" panose="02040503050406030204" pitchFamily="18" charset="0"/>
+                        </a:rPr>
                         <m:t>𝑓</m:t>
                       </m:r>
                       <m:d>
                         <m:dPr>
                           <m:sepChr m:val=","/>
                           <m:ctrlPr>
-                            <a:rPr lang="ar-AE" i="1"/>
+                            <a:rPr lang="ar-AE" i="1">
+                              <a:latin typeface="Cambria Math" panose="02040503050406030204" pitchFamily="18" charset="0"/>
+                            </a:rPr>
                           </m:ctrlPr>
                         </m:dPr>
                         <m:e>
                           <m:sSub>
                             <m:sSubPr>
                               <m:ctrlPr>
-                                <a:rPr lang="ar-AE" i="1"/>
+                                <a:rPr lang="ar-AE" i="1">
+                                  <a:latin typeface="Cambria Math" panose="02040503050406030204" pitchFamily="18" charset="0"/>
+                                </a:rPr>
                               </m:ctrlPr>
                             </m:sSubPr>
                             <m:e>
                               <m:r>
-                                <a:rPr lang="ar-AE" i="1"/>
+                                <a:rPr lang="ar-AE" i="1">
+                                  <a:latin typeface="Cambria Math" panose="02040503050406030204" pitchFamily="18" charset="0"/>
+                                </a:rPr>
                                 <m:t>𝑥</m:t>
                               </m:r>
                             </m:e>
                             <m:sub>
                               <m:r>
-                                <a:rPr lang="ar-AE"/>
+                                <a:rPr lang="ar-AE">
+                                  <a:latin typeface="Cambria Math" panose="02040503050406030204" pitchFamily="18" charset="0"/>
+                                </a:rPr>
                                 <m:t>2</m:t>
                               </m:r>
                             </m:sub>
@@ -11626,18 +11992,24 @@
                           <m:sSub>
                             <m:sSubPr>
                               <m:ctrlPr>
-                                <a:rPr lang="ar-AE" i="1"/>
+                                <a:rPr lang="ar-AE" i="1">
+                                  <a:latin typeface="Cambria Math" panose="02040503050406030204" pitchFamily="18" charset="0"/>
+                                </a:rPr>
                               </m:ctrlPr>
                             </m:sSubPr>
                             <m:e>
                               <m:r>
-                                <a:rPr lang="ar-AE" i="1"/>
+                                <a:rPr lang="ar-AE" i="1">
+                                  <a:latin typeface="Cambria Math" panose="02040503050406030204" pitchFamily="18" charset="0"/>
+                                </a:rPr>
                                 <m:t>𝑦</m:t>
                               </m:r>
                             </m:e>
                             <m:sub>
                               <m:r>
-                                <a:rPr lang="ar-AE"/>
+                                <a:rPr lang="ar-AE">
+                                  <a:latin typeface="Cambria Math" panose="02040503050406030204" pitchFamily="18" charset="0"/>
+                                </a:rPr>
                                 <m:t>1</m:t>
                               </m:r>
                             </m:sub>
@@ -11662,53 +12034,71 @@
                       <m:sSub>
                         <m:sSubPr>
                           <m:ctrlPr>
-                            <a:rPr lang="ar-AE"/>
+                            <a:rPr lang="ar-AE" i="1">
+                              <a:latin typeface="Cambria Math" panose="02040503050406030204" pitchFamily="18" charset="0"/>
+                            </a:rPr>
                           </m:ctrlPr>
                         </m:sSubPr>
                         <m:e>
                           <m:r>
-                            <a:rPr lang="ar-AE" i="1"/>
+                            <a:rPr lang="ar-AE" i="1">
+                              <a:latin typeface="Cambria Math" panose="02040503050406030204" pitchFamily="18" charset="0"/>
+                            </a:rPr>
                             <m:t>𝑄</m:t>
                           </m:r>
                         </m:e>
                         <m:sub>
                           <m:r>
-                            <a:rPr lang="ar-AE"/>
+                            <a:rPr lang="ar-AE">
+                              <a:latin typeface="Cambria Math" panose="02040503050406030204" pitchFamily="18" charset="0"/>
+                            </a:rPr>
                             <m:t>12</m:t>
                           </m:r>
                         </m:sub>
                       </m:sSub>
                       <m:r>
-                        <a:rPr lang="ar-AE"/>
+                        <a:rPr lang="ar-AE">
+                          <a:latin typeface="Cambria Math" panose="02040503050406030204" pitchFamily="18" charset="0"/>
+                        </a:rPr>
                         <m:t>=</m:t>
                       </m:r>
                       <m:r>
-                        <a:rPr lang="ar-AE" i="1"/>
+                        <a:rPr lang="ar-AE" i="1">
+                          <a:latin typeface="Cambria Math" panose="02040503050406030204" pitchFamily="18" charset="0"/>
+                        </a:rPr>
                         <m:t>𝑓</m:t>
                       </m:r>
                       <m:d>
                         <m:dPr>
                           <m:sepChr m:val=","/>
                           <m:ctrlPr>
-                            <a:rPr lang="ar-AE" i="1"/>
+                            <a:rPr lang="ar-AE" i="1">
+                              <a:latin typeface="Cambria Math" panose="02040503050406030204" pitchFamily="18" charset="0"/>
+                            </a:rPr>
                           </m:ctrlPr>
                         </m:dPr>
                         <m:e>
                           <m:sSub>
                             <m:sSubPr>
                               <m:ctrlPr>
-                                <a:rPr lang="ar-AE" i="1"/>
+                                <a:rPr lang="ar-AE" i="1">
+                                  <a:latin typeface="Cambria Math" panose="02040503050406030204" pitchFamily="18" charset="0"/>
+                                </a:rPr>
                               </m:ctrlPr>
                             </m:sSubPr>
                             <m:e>
                               <m:r>
-                                <a:rPr lang="ar-AE" i="1"/>
+                                <a:rPr lang="ar-AE" i="1">
+                                  <a:latin typeface="Cambria Math" panose="02040503050406030204" pitchFamily="18" charset="0"/>
+                                </a:rPr>
                                 <m:t>𝑥</m:t>
                               </m:r>
                             </m:e>
                             <m:sub>
                               <m:r>
-                                <a:rPr lang="ar-AE"/>
+                                <a:rPr lang="ar-AE">
+                                  <a:latin typeface="Cambria Math" panose="02040503050406030204" pitchFamily="18" charset="0"/>
+                                </a:rPr>
                                 <m:t>1</m:t>
                               </m:r>
                             </m:sub>
@@ -11718,18 +12108,24 @@
                           <m:sSub>
                             <m:sSubPr>
                               <m:ctrlPr>
-                                <a:rPr lang="ar-AE" i="1"/>
+                                <a:rPr lang="ar-AE" i="1">
+                                  <a:latin typeface="Cambria Math" panose="02040503050406030204" pitchFamily="18" charset="0"/>
+                                </a:rPr>
                               </m:ctrlPr>
                             </m:sSubPr>
                             <m:e>
                               <m:r>
-                                <a:rPr lang="ar-AE" i="1"/>
+                                <a:rPr lang="ar-AE" i="1">
+                                  <a:latin typeface="Cambria Math" panose="02040503050406030204" pitchFamily="18" charset="0"/>
+                                </a:rPr>
                                 <m:t>𝑦</m:t>
                               </m:r>
                             </m:e>
                             <m:sub>
                               <m:r>
-                                <a:rPr lang="ar-AE"/>
+                                <a:rPr lang="ar-AE">
+                                  <a:latin typeface="Cambria Math" panose="02040503050406030204" pitchFamily="18" charset="0"/>
+                                </a:rPr>
                                 <m:t>2</m:t>
                               </m:r>
                             </m:sub>
@@ -11754,53 +12150,71 @@
                       <m:sSub>
                         <m:sSubPr>
                           <m:ctrlPr>
-                            <a:rPr lang="ar-AE"/>
+                            <a:rPr lang="ar-AE" i="1">
+                              <a:latin typeface="Cambria Math" panose="02040503050406030204" pitchFamily="18" charset="0"/>
+                            </a:rPr>
                           </m:ctrlPr>
                         </m:sSubPr>
                         <m:e>
                           <m:r>
-                            <a:rPr lang="ar-AE" i="1"/>
+                            <a:rPr lang="ar-AE" i="1">
+                              <a:latin typeface="Cambria Math" panose="02040503050406030204" pitchFamily="18" charset="0"/>
+                            </a:rPr>
                             <m:t>𝑄</m:t>
                           </m:r>
                         </m:e>
                         <m:sub>
                           <m:r>
-                            <a:rPr lang="ar-AE"/>
+                            <a:rPr lang="ar-AE">
+                              <a:latin typeface="Cambria Math" panose="02040503050406030204" pitchFamily="18" charset="0"/>
+                            </a:rPr>
                             <m:t>22</m:t>
                           </m:r>
                         </m:sub>
                       </m:sSub>
                       <m:r>
-                        <a:rPr lang="ar-AE"/>
+                        <a:rPr lang="ar-AE">
+                          <a:latin typeface="Cambria Math" panose="02040503050406030204" pitchFamily="18" charset="0"/>
+                        </a:rPr>
                         <m:t>=</m:t>
                       </m:r>
                       <m:r>
-                        <a:rPr lang="ar-AE" i="1"/>
+                        <a:rPr lang="ar-AE" i="1">
+                          <a:latin typeface="Cambria Math" panose="02040503050406030204" pitchFamily="18" charset="0"/>
+                        </a:rPr>
                         <m:t>𝑓</m:t>
                       </m:r>
                       <m:d>
                         <m:dPr>
                           <m:sepChr m:val=","/>
                           <m:ctrlPr>
-                            <a:rPr lang="ar-AE" i="1"/>
+                            <a:rPr lang="ar-AE" i="1">
+                              <a:latin typeface="Cambria Math" panose="02040503050406030204" pitchFamily="18" charset="0"/>
+                            </a:rPr>
                           </m:ctrlPr>
                         </m:dPr>
                         <m:e>
                           <m:sSub>
                             <m:sSubPr>
                               <m:ctrlPr>
-                                <a:rPr lang="ar-AE" i="1"/>
+                                <a:rPr lang="ar-AE" i="1">
+                                  <a:latin typeface="Cambria Math" panose="02040503050406030204" pitchFamily="18" charset="0"/>
+                                </a:rPr>
                               </m:ctrlPr>
                             </m:sSubPr>
                             <m:e>
                               <m:r>
-                                <a:rPr lang="ar-AE" i="1"/>
+                                <a:rPr lang="ar-AE" i="1">
+                                  <a:latin typeface="Cambria Math" panose="02040503050406030204" pitchFamily="18" charset="0"/>
+                                </a:rPr>
                                 <m:t>𝑥</m:t>
                               </m:r>
                             </m:e>
                             <m:sub>
                               <m:r>
-                                <a:rPr lang="ar-AE"/>
+                                <a:rPr lang="ar-AE">
+                                  <a:latin typeface="Cambria Math" panose="02040503050406030204" pitchFamily="18" charset="0"/>
+                                </a:rPr>
                                 <m:t>2</m:t>
                               </m:r>
                             </m:sub>
@@ -11810,18 +12224,24 @@
                           <m:sSub>
                             <m:sSubPr>
                               <m:ctrlPr>
-                                <a:rPr lang="ar-AE" i="1"/>
+                                <a:rPr lang="ar-AE" i="1">
+                                  <a:latin typeface="Cambria Math" panose="02040503050406030204" pitchFamily="18" charset="0"/>
+                                </a:rPr>
                               </m:ctrlPr>
                             </m:sSubPr>
                             <m:e>
                               <m:r>
-                                <a:rPr lang="ar-AE" i="1"/>
+                                <a:rPr lang="ar-AE" i="1">
+                                  <a:latin typeface="Cambria Math" panose="02040503050406030204" pitchFamily="18" charset="0"/>
+                                </a:rPr>
                                 <m:t>𝑦</m:t>
                               </m:r>
                             </m:e>
                             <m:sub>
                               <m:r>
-                                <a:rPr lang="ar-AE"/>
+                                <a:rPr lang="ar-AE">
+                                  <a:latin typeface="Cambria Math" panose="02040503050406030204" pitchFamily="18" charset="0"/>
+                                </a:rPr>
                                 <m:t>2</m:t>
                               </m:r>
                             </m:sub>
@@ -11853,7 +12273,7 @@
             </p:txBody>
           </p:sp>
         </mc:Choice>
-        <mc:Fallback>
+        <mc:Fallback xmlns="">
           <p:sp>
             <p:nvSpPr>
               <p:cNvPr id="3" name="Content Placeholder 2">

</xml_diff>